<commit_message>
Harden closed-loop commerce demo for submission
</commit_message>
<xml_diff>
--- a/Agentic_AI_Checkout.pptx
+++ b/Agentic_AI_Checkout.pptx
@@ -3209,7 +3209,7 @@
                   <a:srgbClr val="1A1A1A"/>
                 </a:solidFill>
               </a:rPr>
-              <a:t>Agentic AI Checkout</a:t>
+              <a:t>Aisle AI</a:t>
             </a:r>
           </a:p>
         </p:txBody>
@@ -3286,7 +3286,7 @@
                   <a:srgbClr val="374151"/>
                 </a:solidFill>
               </a:rPr>
-              <a:t>The 30-Second E-Commerce Revolution</a:t>
+              <a:t>Closed-Loop Commerce, From Intent to Action</a:t>
             </a:r>
           </a:p>
         </p:txBody>
@@ -3320,9 +3320,9 @@
                   <a:srgbClr val="6B7280"/>
                 </a:solidFill>
               </a:rPr>
-              <a:t>A multi-agent AI system that autonomously finds merchants,
-selects products, and completes checkout — transforming
-shopping from manual effort to intelligent automation.</a:t>
+              <a:t>Gemini-assisted discovery prepares a grounded cart; deterministic
+controls persist a customer-confirmed order; merchant signals
+turn into evidence-grounded operational action.</a:t>
             </a:r>
           </a:p>
         </p:txBody>
@@ -3709,7 +3709,7 @@
                   <a:srgbClr val="1A8C4E"/>
                 </a:solidFill>
               </a:rPr>
-              <a:t>🔒  Tokenized Pay</a:t>
+              <a:t>🔒  Human Approval</a:t>
             </a:r>
           </a:p>
         </p:txBody>
@@ -3847,7 +3847,7 @@
                   <a:srgbClr val="1A1A1A"/>
                 </a:solidFill>
               </a:rPr>
-              <a:t>Agentic AI Checkout</a:t>
+              <a:t>Aisle AI</a:t>
             </a:r>
           </a:p>
         </p:txBody>
@@ -4003,7 +4003,7 @@
                   <a:srgbClr val="374151"/>
                 </a:solidFill>
               </a:rPr>
-              <a:t>5 minutes and 12 clicks</a:t>
+              <a:t>Fragmented and repetitive</a:t>
             </a:r>
           </a:p>
         </p:txBody>
@@ -4754,7 +4754,7 @@
         <p:spPr>
           <a:xfrm>
             <a:off x="3749039" y="1408176"/>
-            <a:ext cx="2377440" cy="320040"/>
+            <a:ext cx="2651760" cy="320040"/>
           </a:xfrm>
           <a:prstGeom prst="rect">
             <a:avLst/>
@@ -4774,7 +4774,7 @@
                   <a:srgbClr val="1A8C4E"/>
                 </a:solidFill>
               </a:rPr>
-              <a:t>30 seconds and 2 clicks</a:t>
+              <a:t>one request and one confirmation</a:t>
             </a:r>
           </a:p>
         </p:txBody>
@@ -4887,7 +4887,7 @@
                   <a:srgbClr val="374151"/>
                 </a:solidFill>
               </a:rPr>
-              <a:t>AI agents find merchants</a:t>
+              <a:t>grounded catalog search</a:t>
             </a:r>
           </a:p>
         </p:txBody>
@@ -5043,7 +5043,7 @@
                   <a:srgbClr val="374151"/>
                 </a:solidFill>
               </a:rPr>
-              <a:t>select products</a:t>
+              <a:t>Gemini-assisted selection</a:t>
             </a:r>
           </a:p>
         </p:txBody>
@@ -5199,8 +5199,8 @@
                   <a:srgbClr val="374151"/>
                 </a:solidFill>
               </a:rPr>
-              <a:t>prepare order for
-one-click confirmation</a:t>
+              <a:t>explicit confirmation +
+merchant fulfillment</a:t>
             </a:r>
           </a:p>
         </p:txBody>
@@ -5277,8 +5277,8 @@
                   <a:srgbClr val="1A1A1A"/>
                 </a:solidFill>
               </a:rPr>
-              <a:t>Cart Pilot: The 30-Second
-E-Commerce Revolution</a:t>
+              <a:t>Aisle AI: Closed-Loop
+Commerce Copilot</a:t>
             </a:r>
           </a:p>
         </p:txBody>
@@ -5312,9 +5312,9 @@
                   <a:srgbClr val="374151"/>
                 </a:solidFill>
               </a:rPr>
-              <a:t>A multi-agent AI system that autonomously finds merchants, selects
-products, and prepares orders — transforming online shopping from
-manual labour to intelligent automation.</a:t>
+              <a:t>A governed commerce copilot that connects grounded product discovery,
+explicit customer confirmation, persistent orders, merchant fulfillment,
+and evidence-grounded operational insight.</a:t>
             </a:r>
           </a:p>
         </p:txBody>
@@ -5349,7 +5349,7 @@
                 </a:solidFill>
               </a:rPr>
               <a:t>Manual friction destroys conversion rates and user patience. E-commerce
-remains a labour-intensive chore — and that is the problem Cart Pilot
+remains a labour-intensive chore — and that is the problem Aisle AI
 was built to solve.</a:t>
             </a:r>
           </a:p>
@@ -5429,7 +5429,7 @@
                   <a:srgbClr val="1A8C4E"/>
                 </a:solidFill>
               </a:rPr>
-              <a:t>✓  Cart Pilot doesn't just speed up shopping — it redefines it.</a:t>
+              <a:t>✓  Aisle AI connects customer intent with merchant action.</a:t>
             </a:r>
           </a:p>
         </p:txBody>
@@ -5463,8 +5463,8 @@
                   <a:srgbClr val="374151"/>
                 </a:solidFill>
               </a:rPr>
-              <a:t>From 5 minutes to 30 seconds. From 12 clicks to 2.
-The future of e-commerce is autonomous.</a:t>
+              <a:t>From fragmented browsing to one grounded request and explicit confirmation.
+Customer intent now connects to merchant action.</a:t>
             </a:r>
           </a:p>
         </p:txBody>
@@ -5541,7 +5541,7 @@
                   <a:srgbClr val="1A8C4E"/>
                 </a:solidFill>
               </a:rPr>
-              <a:t>→  Find Merchants</a:t>
+              <a:t>→  Discover</a:t>
             </a:r>
           </a:p>
         </p:txBody>
@@ -5575,8 +5575,8 @@
                   <a:srgbClr val="6B7280"/>
                 </a:solidFill>
               </a:rPr>
-              <a:t>Agents scan and identify
-the best sources instantly</a:t>
+              <a:t>Search a bounded synthetic
+demo catalog</a:t>
             </a:r>
           </a:p>
         </p:txBody>
@@ -5653,7 +5653,7 @@
                   <a:srgbClr val="1A8C4E"/>
                 </a:solidFill>
               </a:rPr>
-              <a:t>→  Select Products</a:t>
+              <a:t>→  Compose</a:t>
             </a:r>
           </a:p>
         </p:txBody>
@@ -5687,8 +5687,8 @@
                   <a:srgbClr val="6B7280"/>
                 </a:solidFill>
               </a:rPr>
-              <a:t>Smart comparison based
-on your intent</a:t>
+              <a:t>Gemini helps satisfy
+intent and constraints</a:t>
             </a:r>
           </a:p>
         </p:txBody>
@@ -5765,7 +5765,7 @@
                   <a:srgbClr val="1A8C4E"/>
                 </a:solidFill>
               </a:rPr>
-              <a:t>→  One-Click Confirmation</a:t>
+              <a:t>→  Close the Loop</a:t>
             </a:r>
           </a:p>
         </p:txBody>
@@ -5799,8 +5799,8 @@
                   <a:srgbClr val="6B7280"/>
                 </a:solidFill>
               </a:rPr>
-              <a:t>Orders prepared and
-ready for instant approval</a:t>
+              <a:t>Confirmed orders reach
+merchant operations</a:t>
             </a:r>
           </a:p>
         </p:txBody>
@@ -6128,7 +6128,7 @@
               </a:rPr>
               <a:t>No browsing. No searching. No checkout forms.
 Simply tell the AI what you want — it finds the best merchant, compares options,
-checks your budget rules, and completes payment. All in under 30 seconds.</a:t>
+checks your budget rules, and prepares an order for explicit confirmation.</a:t>
             </a:r>
           </a:p>
         </p:txBody>
@@ -6341,7 +6341,7 @@
                   <a:srgbClr val="1A8C4E"/>
                 </a:solidFill>
               </a:rPr>
-              <a:t>Found 3 coffee shops on your route. Starbucks (0.1 mi) · Tower Cafe (0.3 mi) · Peet's (0.5 mi). Which would you like?</a:t>
+              <a:t>Found 3 synthetic demo merchants. Aisle Coffee Lab has your latte. Choose it?</a:t>
             </a:r>
           </a:p>
         </p:txBody>
@@ -6409,7 +6409,7 @@
                   <a:srgbClr val="374151"/>
                 </a:solidFill>
               </a:rPr>
-              <a:t>Starbucks.</a:t>
+              <a:t>Aisle Coffee Lab.</a:t>
             </a:r>
           </a:p>
         </p:txBody>
@@ -6477,7 +6477,7 @@
                   <a:srgbClr val="1A8C4E"/>
                 </a:solidFill>
               </a:rPr>
-              <a:t>Adding a Medium Latte — $5.75. Paying via your saved card. Shall I place the order?</a:t>
+              <a:t>Adding a Medium Latte — $5.75. Use a simulated token or COD?</a:t>
             </a:r>
           </a:p>
         </p:txBody>
@@ -6613,7 +6613,7 @@
                   <a:srgbClr val="2DBF6E"/>
                 </a:solidFill>
               </a:rPr>
-              <a:t>✓ Order confirmed! Loyalty points earned. Ready in ~5 mins.</a:t>
+              <a:t>✓ Order confirmed! The merchant can now begin preparation.</a:t>
             </a:r>
           </a:p>
         </p:txBody>
@@ -6801,7 +6801,7 @@
                   <a:srgbClr val="1A8C4E"/>
                 </a:solidFill>
               </a:rPr>
-              <a:t>Shopping Agent</a:t>
+              <a:t>Catalog Retrieval</a:t>
             </a:r>
           </a:p>
         </p:txBody>
@@ -6835,8 +6835,8 @@
                   <a:srgbClr val="374151"/>
                 </a:solidFill>
               </a:rPr>
-              <a:t>Scanned every nearby merchant
-catalog for coffee</a:t>
+              <a:t>Searched bounded synthetic
+merchant records</a:t>
             </a:r>
           </a:p>
         </p:txBody>
@@ -6947,7 +6947,7 @@
                   <a:srgbClr val="1A8C4E"/>
                 </a:solidFill>
               </a:rPr>
-              <a:t>Comparison Agent</a:t>
+              <a:t>Gemini Reasoning</a:t>
             </a:r>
           </a:p>
         </p:txBody>
@@ -6981,8 +6981,8 @@
                   <a:srgbClr val="374151"/>
                 </a:solidFill>
               </a:rPr>
-              <a:t>Ranked by route proximity,
-rating, and price</a:t>
+              <a:t>Interpreted intent and explained
+the grounded recommendation</a:t>
             </a:r>
           </a:p>
         </p:txBody>
@@ -7093,7 +7093,7 @@
                   <a:srgbClr val="1A8C4E"/>
                 </a:solidFill>
               </a:rPr>
-              <a:t>Rules Agent</a:t>
+              <a:t>Commerce Controls</a:t>
             </a:r>
           </a:p>
         </p:txBody>
@@ -7127,8 +7127,8 @@
                   <a:srgbClr val="374151"/>
                 </a:solidFill>
               </a:rPr>
-              <a:t>Checked your spending limits
-before showing options</a:t>
+              <a:t>Recomputed prices and required
+explicit confirmation</a:t>
             </a:r>
           </a:p>
         </p:txBody>
@@ -7239,7 +7239,7 @@
                   <a:srgbClr val="1A8C4E"/>
                 </a:solidFill>
               </a:rPr>
-              <a:t>Checkout Agent</a:t>
+              <a:t>Order Workflow</a:t>
             </a:r>
           </a:p>
         </p:txBody>
@@ -7273,8 +7273,8 @@
                   <a:srgbClr val="374151"/>
                 </a:solidFill>
               </a:rPr>
-              <a:t>Generated a tokenized payment
-token on approval</a:t>
+              <a:t>Persisted the order with honest
+payment status</a:t>
             </a:r>
           </a:p>
         </p:txBody>
@@ -7455,7 +7455,7 @@
                   <a:srgbClr val="1A1A1A"/>
                 </a:solidFill>
               </a:rPr>
-              <a:t>Multi-Agent Architecture</a:t>
+              <a:t>Governed Commerce Architecture</a:t>
             </a:r>
           </a:p>
         </p:txBody>
@@ -7489,7 +7489,7 @@
                   <a:srgbClr val="6B7280"/>
                 </a:solidFill>
               </a:rPr>
-              <a:t>Four specialized AI agents working in concert to deliver a seamless checkout experience.</a:t>
+              <a:t>Gemini reasons over bounded evidence; deterministic services control consequential actions.</a:t>
             </a:r>
           </a:p>
         </p:txBody>
@@ -7600,7 +7600,7 @@
                   <a:srgbClr val="1A8C4E"/>
                 </a:solidFill>
               </a:rPr>
-              <a:t>Shopping Agent</a:t>
+              <a:t>Search &amp; Grounding</a:t>
             </a:r>
           </a:p>
         </p:txBody>
@@ -7677,10 +7677,9 @@
                   <a:srgbClr val="374151"/>
                 </a:solidFill>
               </a:rPr>
-              <a:t>Scans every onboarded merchant
-catalog in real time. Surfaces
-relevant items based on your request,
-location, and preferences.</a:t>
+              <a:t>Retrieves synthetic catalog records.
+Product, price and availability evidence
+stays bounded and inspectable.</a:t>
             </a:r>
           </a:p>
         </p:txBody>
@@ -7791,7 +7790,7 @@
                   <a:srgbClr val="1A1A1A"/>
                 </a:solidFill>
               </a:rPr>
-              <a:t>⚖️</a:t>
+              <a:t>✨</a:t>
             </a:r>
           </a:p>
         </p:txBody>
@@ -7825,7 +7824,7 @@
                   <a:srgbClr val="1D4ED8"/>
                 </a:solidFill>
               </a:rPr>
-              <a:t>Comparison Agent</a:t>
+              <a:t>Gemini Planner</a:t>
             </a:r>
           </a:p>
         </p:txBody>
@@ -7902,10 +7901,9 @@
                   <a:srgbClr val="374151"/>
                 </a:solidFill>
               </a:rPr>
-              <a:t>Ranks results by price, distance,
-rating, and merchant reputation.
-Presents the top options with full
-transparency.</a:t>
+              <a:t>Interprets natural-language intent
+and explains choices. PII is redacted
+and failures use a labelled fallback.</a:t>
             </a:r>
           </a:p>
         </p:txBody>
@@ -8050,7 +8048,7 @@
                   <a:srgbClr val="C2610B"/>
                 </a:solidFill>
               </a:rPr>
-              <a:t>Rules Agent</a:t>
+              <a:t>Commerce Controls</a:t>
             </a:r>
           </a:p>
         </p:txBody>
@@ -8127,10 +8125,9 @@
                   <a:srgbClr val="374151"/>
                 </a:solidFill>
               </a:rPr>
-              <a:t>Validates every transaction against
-your spending rules — monthly budget,
-category limits, and approval thresholds
-— before any option is shown.</a:t>
+              <a:t>Recomputes prices and totals, checks
+roles and ownership, and requires an
+explicit customer confirmation.</a:t>
             </a:r>
           </a:p>
         </p:txBody>
@@ -8275,7 +8272,7 @@
                   <a:srgbClr val="86197A"/>
                 </a:solidFill>
               </a:rPr>
-              <a:t>Checkout Agent</a:t>
+              <a:t>Order Workflow</a:t>
             </a:r>
           </a:p>
         </p:txBody>
@@ -8352,10 +8349,9 @@
                   <a:srgbClr val="374151"/>
                 </a:solidFill>
               </a:rPr>
-              <a:t>Generates a single-use tokenized
-payment credential. Your real card
-number is never exposed to the
-merchant.</a:t>
+              <a:t>Persists customer and merchant views.
+Payment is simulated-token or COD;
+fulfillment follows valid transitions.</a:t>
             </a:r>
           </a:p>
         </p:txBody>
@@ -8613,7 +8609,7 @@
                   <a:srgbClr val="1A1A1A"/>
                 </a:solidFill>
               </a:rPr>
-              <a:t>Tokenized Payment</a:t>
+              <a:t>Responsible AI Controls</a:t>
             </a:r>
           </a:p>
         </p:txBody>
@@ -8647,7 +8643,7 @@
                   <a:srgbClr val="1A8C4E"/>
                 </a:solidFill>
               </a:rPr>
-              <a:t>Your real card number is never shared with any merchant.</a:t>
+              <a:t>Grounded assistance with deterministic controls and human approval.</a:t>
             </a:r>
           </a:p>
         </p:txBody>
@@ -8939,8 +8935,8 @@
                   <a:srgbClr val="374151"/>
                 </a:solidFill>
               </a:rPr>
-              <a:t>Token
-Generated</a:t>
+              <a:t>PII
+Redacted</a:t>
             </a:r>
           </a:p>
         </p:txBody>
@@ -8974,8 +8970,8 @@
                   <a:srgbClr val="6B7280"/>
                 </a:solidFill>
               </a:rPr>
-              <a:t>A one-time token
-is created</a:t>
+              <a:t>Sensitive text is
+removed from prompts</a:t>
             </a:r>
           </a:p>
         </p:txBody>
@@ -9120,8 +9116,8 @@
                   <a:srgbClr val="374151"/>
                 </a:solidFill>
               </a:rPr>
-              <a:t>Token
-Sent</a:t>
+              <a:t>Evidence
+Grounded</a:t>
             </a:r>
           </a:p>
         </p:txBody>
@@ -9155,8 +9151,8 @@
                   <a:srgbClr val="6B7280"/>
                 </a:solidFill>
               </a:rPr>
-              <a:t>Only token goes
-to merchant</a:t>
+              <a:t>Catalog and metrics
+bound the answer</a:t>
             </a:r>
           </a:p>
         </p:txBody>
@@ -9301,8 +9297,8 @@
                   <a:srgbClr val="374151"/>
                 </a:solidFill>
               </a:rPr>
-              <a:t>Payment
-Completed</a:t>
+              <a:t>Order
+Persisted</a:t>
             </a:r>
           </a:p>
         </p:txBody>
@@ -9336,8 +9332,8 @@
                   <a:srgbClr val="6B7280"/>
                 </a:solidFill>
               </a:rPr>
-              <a:t>Token expires
-immediately</a:t>
+              <a:t>Simulated token
+or COD status</a:t>
             </a:r>
           </a:p>
         </p:txBody>
@@ -9482,8 +9478,8 @@
                   <a:srgbClr val="374151"/>
                 </a:solidFill>
               </a:rPr>
-              <a:t>Receipt +
-Rewards</a:t>
+              <a:t>Merchant
+Controls</a:t>
             </a:r>
           </a:p>
         </p:txBody>
@@ -9517,8 +9513,8 @@
                   <a:srgbClr val="6B7280"/>
                 </a:solidFill>
               </a:rPr>
-              <a:t>Customer gets
-confirmation</a:t>
+              <a:t>Status changes are
+explicitly approved</a:t>
             </a:r>
           </a:p>
         </p:txBody>
@@ -9629,7 +9625,7 @@
                   <a:srgbClr val="374151"/>
                 </a:solidFill>
               </a:rPr>
-              <a:t>✓  Zero merchant card exposure — eliminates card-skimming risk</a:t>
+              <a:t>✓  PII redaction before model calls and on model output</a:t>
             </a:r>
           </a:p>
         </p:txBody>
@@ -9663,7 +9659,7 @@
                   <a:srgbClr val="374151"/>
                 </a:solidFill>
               </a:rPr>
-              <a:t>✓  Single-use token expires the moment payment is complete</a:t>
+              <a:t>✓  Prompt-injection boundary for reviews and customer text</a:t>
             </a:r>
           </a:p>
         </p:txBody>
@@ -9697,7 +9693,7 @@
                   <a:srgbClr val="374151"/>
                 </a:solidFill>
               </a:rPr>
-              <a:t>✓  Even in a data breach, the token is worthless to attackers</a:t>
+              <a:t>✓  Deterministic price, policy, authentication, and order controls</a:t>
             </a:r>
           </a:p>
         </p:txBody>
@@ -9731,7 +9727,7 @@
                   <a:srgbClr val="374151"/>
                 </a:solidFill>
               </a:rPr>
-              <a:t>✓  Full PCI-compliant flow — customer card details never transit merchant systems</a:t>
+              <a:t>✓  Transparent fallbacks and prototype limitations</a:t>
             </a:r>
           </a:p>
         </p:txBody>
@@ -9912,7 +9908,7 @@
                   <a:srgbClr val="1A1A1A"/>
                 </a:solidFill>
               </a:rPr>
-              <a:t>Loyalty Rewards  &amp;  Merchant Console</a:t>
+              <a:t>Demand Intelligence  &amp;  Merchant Operations</a:t>
             </a:r>
           </a:p>
         </p:txBody>
@@ -9989,7 +9985,7 @@
                   <a:srgbClr val="1A8C4E"/>
                 </a:solidFill>
               </a:rPr>
-              <a:t>🎁  Loyalty Rewards</a:t>
+              <a:t>📈  Demand Intelligence</a:t>
             </a:r>
           </a:p>
         </p:txBody>
@@ -10023,9 +10019,9 @@
                   <a:srgbClr val="374151"/>
                 </a:solidFill>
               </a:rPr>
-              <a:t>Every transaction automatically earns points.
-No sign-up forms. No manual redemption.
-The AI handles it all.</a:t>
+              <a:t>Historical order patterns become directional forecasts.
+Gemini explains the evidence and suggests preparation,
+while the merchant keeps decision authority.</a:t>
             </a:r>
           </a:p>
         </p:txBody>
@@ -10102,7 +10098,7 @@
                   <a:srgbClr val="FFFFFF"/>
                 </a:solidFill>
               </a:rPr>
-              <a:t>$1 spent</a:t>
+              <a:t>Evidence</a:t>
             </a:r>
           </a:p>
         </p:txBody>
@@ -10136,7 +10132,7 @@
                   <a:srgbClr val="374151"/>
                 </a:solidFill>
               </a:rPr>
-              <a:t>= 1 loyalty point</a:t>
+              <a:t>historical weekday and item patterns</a:t>
             </a:r>
           </a:p>
         </p:txBody>
@@ -10213,7 +10209,7 @@
                   <a:srgbClr val="FFFFFF"/>
                 </a:solidFill>
               </a:rPr>
-              <a:t>Points visible</a:t>
+              <a:t>Explainable</a:t>
             </a:r>
           </a:p>
         </p:txBody>
@@ -10247,7 +10243,7 @@
                   <a:srgbClr val="374151"/>
                 </a:solidFill>
               </a:rPr>
-              <a:t>instantly after order confirmation</a:t>
+              <a:t>sample size and source shown to merchant</a:t>
             </a:r>
           </a:p>
         </p:txBody>
@@ -10324,7 +10320,7 @@
                   <a:srgbClr val="FFFFFF"/>
                 </a:solidFill>
               </a:rPr>
-              <a:t>Auto-applied</a:t>
+              <a:t>Actionable</a:t>
             </a:r>
           </a:p>
         </p:txBody>
@@ -10358,7 +10354,7 @@
                   <a:srgbClr val="374151"/>
                 </a:solidFill>
               </a:rPr>
-              <a:t>on next eligible purchase</a:t>
+              <a:t>stock-preparation guidance, not guarantees</a:t>
             </a:r>
           </a:p>
         </p:txBody>
@@ -10435,7 +10431,7 @@
                   <a:srgbClr val="FFFFFF"/>
                 </a:solidFill>
               </a:rPr>
-              <a:t>No expiry</a:t>
+              <a:t>Resilient</a:t>
             </a:r>
           </a:p>
         </p:txBody>
@@ -10469,7 +10465,7 @@
                   <a:srgbClr val="374151"/>
                 </a:solidFill>
               </a:rPr>
-              <a:t>points never expire</a:t>
+              <a:t>deterministic fallback if Gemini is unavailable</a:t>
             </a:r>
           </a:p>
         </p:txBody>
@@ -10580,8 +10576,8 @@
                   <a:srgbClr val="374151"/>
                 </a:solidFill>
               </a:rPr>
-              <a:t>Real-time order visibility for every onboarded merchant.
-No separate POS system needed.</a:t>
+              <a:t>Live application order visibility for the signed-in merchant,
+with deterministic status transitions.</a:t>
             </a:r>
           </a:p>
         </p:txBody>
@@ -10726,7 +10722,7 @@
                   <a:srgbClr val="6B7280"/>
                 </a:solidFill>
               </a:rPr>
-              <a:t>Instant notification with full order details</a:t>
+              <a:t>Persistent customer-confirmed order details</a:t>
             </a:r>
           </a:p>
         </p:txBody>
@@ -11016,7 +11012,7 @@
                   <a:srgbClr val="6B7280"/>
                 </a:solidFill>
               </a:rPr>
-              <a:t>Status updates pushed to customer in real time</a:t>
+              <a:t>Status is persisted and visible to the customer</a:t>
             </a:r>
           </a:p>
         </p:txBody>
@@ -11161,7 +11157,7 @@
                   <a:srgbClr val="6B7280"/>
                 </a:solidFill>
               </a:rPr>
-              <a:t>Order closed — payment already settled</a:t>
+              <a:t>Order closes with its honest payment status</a:t>
             </a:r>
           </a:p>
         </p:txBody>
@@ -11343,7 +11339,7 @@
                 </a:solidFill>
               </a:rPr>
               <a:t>The Future of Commerce
-Is Autonomous.</a:t>
+Is Closed-Loop.</a:t>
             </a:r>
           </a:p>
         </p:txBody>
@@ -11420,8 +11416,8 @@
                   <a:srgbClr val="374151"/>
                 </a:solidFill>
               </a:rPr>
-              <a:t>Cart Pilot delivers a complete end-to-end agentic shopping experience —
-from spoken intent to confirmed order — in under 30 seconds.</a:t>
+              <a:t>Aisle AI delivers a closed-loop shopping and merchant experience —
+from spoken intent to confirmed order and operational action.</a:t>
             </a:r>
           </a:p>
         </p:txBody>
@@ -11532,7 +11528,7 @@
                   <a:srgbClr val="1A8C4E"/>
                 </a:solidFill>
               </a:rPr>
-              <a:t>Hands-Free Ordering</a:t>
+              <a:t>Conversational Ordering</a:t>
             </a:r>
           </a:p>
         </p:txBody>
@@ -11566,7 +11562,7 @@
                   <a:srgbClr val="6B7280"/>
                 </a:solidFill>
               </a:rPr>
-              <a:t>Just talk — AI handles everything from search to payment</a:t>
+              <a:t>Talk or type; Gemini prepares a grounded cart for confirmation</a:t>
             </a:r>
           </a:p>
         </p:txBody>
@@ -11711,7 +11707,7 @@
                   <a:srgbClr val="6B7280"/>
                 </a:solidFill>
               </a:rPr>
-              <a:t>Agents find the best local merchants and products instantly</a:t>
+              <a:t>Gemini reasons over bounded synthetic catalog evidence</a:t>
             </a:r>
           </a:p>
         </p:txBody>
@@ -11822,7 +11818,7 @@
                   <a:srgbClr val="1A8C4E"/>
                 </a:solidFill>
               </a:rPr>
-              <a:t>Spend Rule Enforcement</a:t>
+              <a:t>Deterministic Commerce</a:t>
             </a:r>
           </a:p>
         </p:txBody>
@@ -11856,7 +11852,7 @@
                   <a:srgbClr val="6B7280"/>
                 </a:solidFill>
               </a:rPr>
-              <a:t>Budget and category limits checked before any transaction</a:t>
+              <a:t>Prices, roles, confirmation, payment status and order transitions are controlled</a:t>
             </a:r>
           </a:p>
         </p:txBody>
@@ -11967,7 +11963,7 @@
                   <a:srgbClr val="1A8C4E"/>
                 </a:solidFill>
               </a:rPr>
-              <a:t>Tokenized Security</a:t>
+              <a:t>Responsible AI</a:t>
             </a:r>
           </a:p>
         </p:txBody>
@@ -12001,7 +11997,7 @@
                   <a:srgbClr val="6B7280"/>
                 </a:solidFill>
               </a:rPr>
-              <a:t>One-use tokens keep your card details 100% private</a:t>
+              <a:t>PII redaction, grounding, role isolation, and human approval</a:t>
             </a:r>
           </a:p>
         </p:txBody>
@@ -12078,7 +12074,7 @@
                   <a:srgbClr val="1A1A1A"/>
                 </a:solidFill>
               </a:rPr>
-              <a:t>🎁</a:t>
+              <a:t>📈</a:t>
             </a:r>
           </a:p>
         </p:txBody>
@@ -12112,7 +12108,7 @@
                   <a:srgbClr val="1A8C4E"/>
                 </a:solidFill>
               </a:rPr>
-              <a:t>Automatic Loyalty</a:t>
+              <a:t>Demand Intelligence</a:t>
             </a:r>
           </a:p>
         </p:txBody>
@@ -12146,7 +12142,7 @@
                   <a:srgbClr val="6B7280"/>
                 </a:solidFill>
               </a:rPr>
-              <a:t>Points earned and applied without any manual effort</a:t>
+              <a:t>Directional forecasts explain the historical evidence used</a:t>
             </a:r>
           </a:p>
         </p:txBody>
@@ -12291,7 +12287,7 @@
                   <a:srgbClr val="6B7280"/>
                 </a:solidFill>
               </a:rPr>
-              <a:t>Real-time order management for every onboarded merchant</a:t>
+              <a:t>Persistent order workflow and evidence-grounded customer insights</a:t>
             </a:r>
           </a:p>
         </p:txBody>
@@ -12368,7 +12364,7 @@
                   <a:srgbClr val="FFFFFF"/>
                 </a:solidFill>
               </a:rPr>
-              <a:t>From intent to checkout in 30 seconds.  No multiple apps.  No friction.  Just AI.</a:t>
+              <a:t>From customer intent to merchant action — one transparent, Gemini-powered loop.</a:t>
             </a:r>
           </a:p>
         </p:txBody>

</xml_diff>